<commit_message>
Eval deck v3: fix slide flow (fitting before pile, test-data slide before methods), de-duplicate intro, lean pipeline chart, merge synth setup into results
</commit_message>
<xml_diff>
--- a/researchwrite/evaluation_presentation.pptx
+++ b/researchwrite/evaluation_presentation.pptx
@@ -3399,7 +3399,7 @@
                 </a:solidFill>
                 <a:latin typeface="Calibri"/>
               </a:rPr>
-              <a:t>Experiment 2 — a real barrel, no occlusion</a:t>
+              <a:t>Experiment 2 — the real lab barrel, no occlusion</a:t>
             </a:r>
           </a:p>
           <a:p>
@@ -3415,7 +3415,7 @@
                 </a:solidFill>
                 <a:latin typeface="Calibri"/>
               </a:rPr>
-              <a:t>Small lab barrel (radius 4.25 cm) seen by a depth camera</a:t>
+              <a:t>Depth-camera scan; true radius 4.25 cm</a:t>
             </a:r>
           </a:p>
         </p:txBody>
@@ -4677,7 +4677,7 @@
                 </a:solidFill>
                 <a:latin typeface="Calibri"/>
               </a:rPr>
-              <a:t>four examples of the computer-generated training data: simulated LiDAR points (red) on a drum surface (blue)</a:t>
+              <a:t>examples of the synthetic training patches: simulated LiDAR points (red) on the drum surface (blue)</a:t>
             </a:r>
           </a:p>
         </p:txBody>
@@ -4716,7 +4716,7 @@
                 </a:solidFill>
                 <a:latin typeface="Calibri"/>
               </a:rPr>
-              <a:t>• Trained on 12,000 randomly generated partial drums — buried, tilted, noisy, incomplete.</a:t>
+              <a:t>• Trained on 12,000 such patches — buried, tilted, noisy, incomplete.</a:t>
             </a:r>
           </a:p>
         </p:txBody>
@@ -5628,7 +5628,7 @@
                 </a:solidFill>
                 <a:latin typeface="Calibri"/>
               </a:rPr>
-              <a:t>• Real sensor noise is structured, not the clean random noise we simulate.</a:t>
+              <a:t>• Real sensor noise is harder than anything we simulate — Experiment 2 showed 6–8× larger errors.</a:t>
             </a:r>
           </a:p>
           <a:p>
@@ -7000,22 +7000,6 @@
               <a:t>The bin-picking problem</a:t>
             </a:r>
           </a:p>
-          <a:p>
-            <a:pPr algn="l">
-              <a:spcAft>
-                <a:spcPts val="800"/>
-              </a:spcAft>
-            </a:pPr>
-            <a:r>
-              <a:rPr sz="1700" b="0" i="0">
-                <a:solidFill>
-                  <a:srgbClr val="D6E6F0"/>
-                </a:solidFill>
-                <a:latin typeface="Calibri"/>
-              </a:rPr>
-              <a:t>A robot must pick objects out of an unordered pile</a:t>
-            </a:r>
-          </a:p>
         </p:txBody>
       </p:sp>
       <p:pic>
@@ -7034,8 +7018,8 @@
         </p:blipFill>
         <p:spPr>
           <a:xfrm>
-            <a:off x="1358122" y="1325880"/>
-            <a:ext cx="9445275" cy="4480560"/>
+            <a:off x="1133012" y="1325880"/>
+            <a:ext cx="9895496" cy="4480560"/>
           </a:xfrm>
           <a:prstGeom prst="rect">
             <a:avLst/>
@@ -7275,7 +7259,7 @@
                 </a:solidFill>
                 <a:latin typeface="Calibri"/>
               </a:rPr>
-              <a:t>Our case is harder: the objects are covered</a:t>
+              <a:t>Our task: fit a cylinder to the visible points</a:t>
             </a:r>
           </a:p>
           <a:p>
@@ -7291,14 +7275,14 @@
                 </a:solidFill>
                 <a:latin typeface="Calibri"/>
               </a:rPr>
-              <a:t>Real scan: 200-litre steel drums, tumbled and partially buried</a:t>
+              <a:t>“Fitting” = choosing model parameters so the model matches the measured points as well as possible</a:t>
             </a:r>
           </a:p>
         </p:txBody>
       </p:sp>
       <p:pic>
         <p:nvPicPr>
-          <p:cNvPr id="4" name="Picture 3" descr="station1_pile_raw.png"/>
+          <p:cNvPr id="4" name="Picture 3" descr="fitting_explained.png"/>
           <p:cNvPicPr>
             <a:picLocks noChangeAspect="1"/>
           </p:cNvPicPr>
@@ -7312,8 +7296,8 @@
         </p:blipFill>
         <p:spPr>
           <a:xfrm>
-            <a:off x="365760" y="1859280"/>
-            <a:ext cx="8229600" cy="3413760"/>
+            <a:off x="365760" y="1596169"/>
+            <a:ext cx="11475720" cy="3939981"/>
           </a:xfrm>
           <a:prstGeom prst="rect">
             <a:avLst/>
@@ -7322,78 +7306,7 @@
       </p:pic>
       <p:sp>
         <p:nvSpPr>
-          <p:cNvPr id="5" name="TextBox 4"/>
-          <p:cNvSpPr txBox="1"/>
-          <p:nvPr/>
-        </p:nvSpPr>
-        <p:spPr>
-          <a:xfrm>
-            <a:off x="8732520" y="1554480"/>
-            <a:ext cx="3246120" cy="4206240"/>
-          </a:xfrm>
-          <a:prstGeom prst="rect">
-            <a:avLst/>
-          </a:prstGeom>
-          <a:noFill/>
-        </p:spPr>
-        <p:txBody>
-          <a:bodyPr wrap="square">
-            <a:spAutoFit/>
-          </a:bodyPr>
-          <a:lstStyle/>
-          <a:p>
-            <a:pPr algn="l">
-              <a:spcAft>
-                <a:spcPts val="1000"/>
-              </a:spcAft>
-            </a:pPr>
-            <a:r>
-              <a:rPr sz="1900" b="0" i="0">
-                <a:solidFill>
-                  <a:srgbClr val="1F2D3D"/>
-                </a:solidFill>
-                <a:latin typeface="Calibri"/>
-              </a:rPr>
-              <a:t>• Drums lie in arbitrary directions.</a:t>
-            </a:r>
-          </a:p>
-          <a:p>
-            <a:pPr algn="l">
-              <a:spcAft>
-                <a:spcPts val="1000"/>
-              </a:spcAft>
-            </a:pPr>
-            <a:r>
-              <a:rPr sz="1900" b="0" i="0">
-                <a:solidFill>
-                  <a:srgbClr val="1F2D3D"/>
-                </a:solidFill>
-                <a:latin typeface="Calibri"/>
-              </a:rPr>
-              <a:t>• Sand and other drums hide most of each drum.</a:t>
-            </a:r>
-          </a:p>
-          <a:p>
-            <a:pPr algn="l">
-              <a:spcAft>
-                <a:spcPts val="1000"/>
-              </a:spcAft>
-            </a:pPr>
-            <a:r>
-              <a:rPr sz="1900" b="0" i="0">
-                <a:solidFill>
-                  <a:srgbClr val="1F2D3D"/>
-                </a:solidFill>
-                <a:latin typeface="Calibri"/>
-              </a:rPr>
-              <a:t>• The sensor sees the pile from one side only.</a:t>
-            </a:r>
-          </a:p>
-        </p:txBody>
-      </p:sp>
-      <p:sp>
-        <p:nvSpPr>
-          <p:cNvPr id="6" name="Rectangle 5"/>
+          <p:cNvPr id="5" name="Rectangle 4"/>
           <p:cNvSpPr/>
           <p:nvPr/>
         </p:nvSpPr>
@@ -7410,7 +7323,7 @@
           </a:solidFill>
           <a:ln w="19050">
             <a:solidFill>
-              <a:srgbClr val="B76E00"/>
+              <a:srgbClr val="0B5C8A"/>
             </a:solidFill>
           </a:ln>
           <a:effectLst/>
@@ -7441,18 +7354,18 @@
             <a:r>
               <a:rPr sz="2000" b="1" i="0">
                 <a:solidFill>
-                  <a:srgbClr val="B76E00"/>
-                </a:solidFill>
-                <a:latin typeface="Calibri"/>
-              </a:rPr>
-              <a:t>Each drum shows the sensor only a small patch of its surface.</a:t>
-            </a:r>
-          </a:p>
-        </p:txBody>
-      </p:sp>
-      <p:sp>
-        <p:nvSpPr>
-          <p:cNvPr id="7" name="TextBox 6"/>
+                  <a:srgbClr val="0B5C8A"/>
+                </a:solidFill>
+                <a:latin typeface="Calibri"/>
+              </a:rPr>
+              <a:t>With a full view, fitting is easy — the difficulty starts when most of the object is hidden.</a:t>
+            </a:r>
+          </a:p>
+        </p:txBody>
+      </p:sp>
+      <p:sp>
+        <p:nvSpPr>
+          <p:cNvPr id="6" name="TextBox 5"/>
           <p:cNvSpPr txBox="1"/>
           <p:nvPr/>
         </p:nvSpPr>
@@ -7491,7 +7404,7 @@
       </p:sp>
       <p:sp>
         <p:nvSpPr>
-          <p:cNvPr id="8" name="TextBox 7"/>
+          <p:cNvPr id="7" name="TextBox 6"/>
           <p:cNvSpPr txBox="1"/>
           <p:nvPr/>
         </p:nvSpPr>
@@ -7624,7 +7537,7 @@
                 </a:solidFill>
                 <a:latin typeface="Calibri"/>
               </a:rPr>
-              <a:t>Our task: fit a cylinder to the visible points</a:t>
+              <a:t>Our case is harder: the drums are covered</a:t>
             </a:r>
           </a:p>
           <a:p>
@@ -7640,14 +7553,14 @@
                 </a:solidFill>
                 <a:latin typeface="Calibri"/>
               </a:rPr>
-              <a:t>“Fitting” = choosing model parameters so the model matches the measured points as well as possible</a:t>
+              <a:t>Real scan: 200-litre steel drums, tumbled and partially buried</a:t>
             </a:r>
           </a:p>
         </p:txBody>
       </p:sp>
       <p:pic>
         <p:nvPicPr>
-          <p:cNvPr id="4" name="Picture 3" descr="fitting_explained.png"/>
+          <p:cNvPr id="4" name="Picture 3" descr="station1_pile_raw.png"/>
           <p:cNvPicPr>
             <a:picLocks noChangeAspect="1"/>
           </p:cNvPicPr>
@@ -7661,8 +7574,8 @@
         </p:blipFill>
         <p:spPr>
           <a:xfrm>
-            <a:off x="365760" y="1596169"/>
-            <a:ext cx="11475720" cy="3939981"/>
+            <a:off x="365760" y="1859280"/>
+            <a:ext cx="8229600" cy="3413760"/>
           </a:xfrm>
           <a:prstGeom prst="rect">
             <a:avLst/>
@@ -7671,7 +7584,78 @@
       </p:pic>
       <p:sp>
         <p:nvSpPr>
-          <p:cNvPr id="5" name="Rectangle 4"/>
+          <p:cNvPr id="5" name="TextBox 4"/>
+          <p:cNvSpPr txBox="1"/>
+          <p:nvPr/>
+        </p:nvSpPr>
+        <p:spPr>
+          <a:xfrm>
+            <a:off x="8732520" y="1554480"/>
+            <a:ext cx="3246120" cy="4206240"/>
+          </a:xfrm>
+          <a:prstGeom prst="rect">
+            <a:avLst/>
+          </a:prstGeom>
+          <a:noFill/>
+        </p:spPr>
+        <p:txBody>
+          <a:bodyPr wrap="square">
+            <a:spAutoFit/>
+          </a:bodyPr>
+          <a:lstStyle/>
+          <a:p>
+            <a:pPr algn="l">
+              <a:spcAft>
+                <a:spcPts val="1000"/>
+              </a:spcAft>
+            </a:pPr>
+            <a:r>
+              <a:rPr sz="1900" b="0" i="0">
+                <a:solidFill>
+                  <a:srgbClr val="1F2D3D"/>
+                </a:solidFill>
+                <a:latin typeface="Calibri"/>
+              </a:rPr>
+              <a:t>• Drums lie in arbitrary directions.</a:t>
+            </a:r>
+          </a:p>
+          <a:p>
+            <a:pPr algn="l">
+              <a:spcAft>
+                <a:spcPts val="1000"/>
+              </a:spcAft>
+            </a:pPr>
+            <a:r>
+              <a:rPr sz="1900" b="0" i="0">
+                <a:solidFill>
+                  <a:srgbClr val="1F2D3D"/>
+                </a:solidFill>
+                <a:latin typeface="Calibri"/>
+              </a:rPr>
+              <a:t>• Sand and other drums hide most of each drum.</a:t>
+            </a:r>
+          </a:p>
+          <a:p>
+            <a:pPr algn="l">
+              <a:spcAft>
+                <a:spcPts val="1000"/>
+              </a:spcAft>
+            </a:pPr>
+            <a:r>
+              <a:rPr sz="1900" b="0" i="0">
+                <a:solidFill>
+                  <a:srgbClr val="1F2D3D"/>
+                </a:solidFill>
+                <a:latin typeface="Calibri"/>
+              </a:rPr>
+              <a:t>• The sensor sees the pile from one side only.</a:t>
+            </a:r>
+          </a:p>
+        </p:txBody>
+      </p:sp>
+      <p:sp>
+        <p:nvSpPr>
+          <p:cNvPr id="6" name="Rectangle 5"/>
           <p:cNvSpPr/>
           <p:nvPr/>
         </p:nvSpPr>
@@ -7723,14 +7707,14 @@
                 </a:solidFill>
                 <a:latin typeface="Calibri"/>
               </a:rPr>
-              <a:t>The less of the barrel we see, the more cylinders explain the same points — that is the core difficulty.</a:t>
-            </a:r>
-          </a:p>
-        </p:txBody>
-      </p:sp>
-      <p:sp>
-        <p:nvSpPr>
-          <p:cNvPr id="6" name="TextBox 5"/>
+              <a:t>Each drum shows only a small patch — and a small patch fits many different cylinders.</a:t>
+            </a:r>
+          </a:p>
+        </p:txBody>
+      </p:sp>
+      <p:sp>
+        <p:nvSpPr>
+          <p:cNvPr id="7" name="TextBox 6"/>
           <p:cNvSpPr txBox="1"/>
           <p:nvPr/>
         </p:nvSpPr>
@@ -7769,7 +7753,7 @@
       </p:sp>
       <p:sp>
         <p:nvSpPr>
-          <p:cNvPr id="7" name="TextBox 6"/>
+          <p:cNvPr id="8" name="TextBox 7"/>
           <p:cNvSpPr txBox="1"/>
           <p:nvPr/>
         </p:nvSpPr>
@@ -8421,7 +8405,7 @@
                 </a:solidFill>
                 <a:latin typeface="Calibri"/>
               </a:rPr>
-              <a:t>Plan: start with the geometry-based family (no data needed), then add learning and fusion as data arrives.</a:t>
+              <a:t>We compare all three families on the same data — geometry first, since it needs no training data.</a:t>
             </a:r>
           </a:p>
         </p:txBody>
@@ -8600,7 +8584,7 @@
                 </a:solidFill>
                 <a:latin typeface="Calibri"/>
               </a:rPr>
-              <a:t>Four geometry-based methods implemented</a:t>
+              <a:t>The data we test every method on</a:t>
             </a:r>
           </a:p>
           <a:p>
@@ -8616,101 +8600,14 @@
                 </a:solidFill>
                 <a:latin typeface="Calibri"/>
               </a:rPr>
-              <a:t>Each explained in one sentence — details on request</a:t>
-            </a:r>
-          </a:p>
-        </p:txBody>
-      </p:sp>
-      <p:sp>
-        <p:nvSpPr>
-          <p:cNvPr id="4" name="TextBox 3"/>
-          <p:cNvSpPr txBox="1"/>
-          <p:nvPr/>
-        </p:nvSpPr>
-        <p:spPr>
-          <a:xfrm>
-            <a:off x="457200" y="1417320"/>
-            <a:ext cx="11338560" cy="2468880"/>
-          </a:xfrm>
-          <a:prstGeom prst="rect">
-            <a:avLst/>
-          </a:prstGeom>
-          <a:noFill/>
-        </p:spPr>
-        <p:txBody>
-          <a:bodyPr wrap="square">
-            <a:spAutoFit/>
-          </a:bodyPr>
-          <a:lstStyle/>
-          <a:p>
-            <a:pPr algn="l">
-              <a:spcAft>
-                <a:spcPts val="1000"/>
-              </a:spcAft>
-            </a:pPr>
-            <a:r>
-              <a:rPr sz="1900" b="0" i="0">
-                <a:solidFill>
-                  <a:srgbClr val="1F2D3D"/>
-                </a:solidFill>
-                <a:latin typeface="Calibri"/>
-              </a:rPr>
-              <a:t>• 3DTK Hough (baseline) — every point votes for the cylinders it could lie on; the strongest vote wins.</a:t>
-            </a:r>
-          </a:p>
-          <a:p>
-            <a:pPr algn="l">
-              <a:spcAft>
-                <a:spcPts val="1000"/>
-              </a:spcAft>
-            </a:pPr>
-            <a:r>
-              <a:rPr sz="1900" b="0" i="0">
-                <a:solidFill>
-                  <a:srgbClr val="1F2D3D"/>
-                </a:solidFill>
-                <a:latin typeface="Calibri"/>
-              </a:rPr>
-              <a:t>• RANSAC fit — try many random small point samples, keep the cylinder most points agree with.</a:t>
-            </a:r>
-          </a:p>
-          <a:p>
-            <a:pPr algn="l">
-              <a:spcAft>
-                <a:spcPts val="1000"/>
-              </a:spcAft>
-            </a:pPr>
-            <a:r>
-              <a:rPr sz="1900" b="0" i="0">
-                <a:solidFill>
-                  <a:srgbClr val="1F2D3D"/>
-                </a:solidFill>
-                <a:latin typeface="Calibri"/>
-              </a:rPr>
-              <a:t>• Least-squares fit — start from a rough guess, then adjust the cylinder until it matches the points best.</a:t>
-            </a:r>
-          </a:p>
-          <a:p>
-            <a:pPr algn="l">
-              <a:spcAft>
-                <a:spcPts val="1000"/>
-              </a:spcAft>
-            </a:pPr>
-            <a:r>
-              <a:rPr sz="1900" b="0" i="0">
-                <a:solidFill>
-                  <a:srgbClr val="1F2D3D"/>
-                </a:solidFill>
-                <a:latin typeface="Calibri"/>
-              </a:rPr>
-              <a:t>• Efficient RANSAC — a faster RANSAC variant that searches the whole scene for shapes in one pass.</a:t>
+              <a:t>Three data sets — difficulty increases left to right</a:t>
             </a:r>
           </a:p>
         </p:txBody>
       </p:sp>
       <p:pic>
         <p:nvPicPr>
-          <p:cNvPr id="5" name="Picture 4" descr="architecture_diagram.png"/>
+          <p:cNvPr id="4" name="Picture 3" descr="test_data_overview.png"/>
           <p:cNvPicPr>
             <a:picLocks noChangeAspect="1"/>
           </p:cNvPicPr>
@@ -8724,8 +8621,8 @@
         </p:blipFill>
         <p:spPr>
           <a:xfrm>
-            <a:off x="3589021" y="3977639"/>
-            <a:ext cx="4983477" cy="1874519"/>
+            <a:off x="274320" y="1504403"/>
+            <a:ext cx="11612880" cy="4123513"/>
           </a:xfrm>
           <a:prstGeom prst="rect">
             <a:avLst/>
@@ -8734,13 +8631,13 @@
       </p:pic>
       <p:sp>
         <p:nvSpPr>
-          <p:cNvPr id="6" name="Rectangle 5"/>
+          <p:cNvPr id="5" name="Rectangle 4"/>
           <p:cNvSpPr/>
           <p:nvPr/>
         </p:nvSpPr>
         <p:spPr>
           <a:xfrm>
-            <a:off x="365760" y="5943600"/>
+            <a:off x="365760" y="5897880"/>
             <a:ext cx="11475720" cy="502920"/>
           </a:xfrm>
           <a:prstGeom prst="rect">
@@ -8786,14 +8683,14 @@
                 </a:solidFill>
                 <a:latin typeface="Calibri"/>
               </a:rPr>
-              <a:t>All four: LiDAR points only · no training data · identical input and output — directly comparable.</a:t>
-            </a:r>
-          </a:p>
-        </p:txBody>
-      </p:sp>
-      <p:sp>
-        <p:nvSpPr>
-          <p:cNvPr id="7" name="TextBox 6"/>
+              <a:t>Synthetic clouds tell us the best case; the real pile tells us the truth.</a:t>
+            </a:r>
+          </a:p>
+        </p:txBody>
+      </p:sp>
+      <p:sp>
+        <p:nvSpPr>
+          <p:cNvPr id="6" name="TextBox 5"/>
           <p:cNvSpPr txBox="1"/>
           <p:nvPr/>
         </p:nvSpPr>
@@ -8832,7 +8729,7 @@
       </p:sp>
       <p:sp>
         <p:nvSpPr>
-          <p:cNvPr id="8" name="TextBox 7"/>
+          <p:cNvPr id="7" name="TextBox 6"/>
           <p:cNvSpPr txBox="1"/>
           <p:nvPr/>
         </p:nvSpPr>
@@ -8965,35 +8862,98 @@
                 </a:solidFill>
                 <a:latin typeface="Calibri"/>
               </a:rPr>
-              <a:t>How we evaluate — one pipeline for every method</a:t>
-            </a:r>
-          </a:p>
-        </p:txBody>
-      </p:sp>
-      <p:pic>
-        <p:nvPicPr>
-          <p:cNvPr id="4" name="Picture 3" descr="pipeline_flow.png"/>
-          <p:cNvPicPr>
-            <a:picLocks noChangeAspect="1"/>
-          </p:cNvPicPr>
-          <p:nvPr/>
-        </p:nvPicPr>
-        <p:blipFill>
-          <a:blip r:embed="rId2"/>
-          <a:stretch>
-            <a:fillRect/>
-          </a:stretch>
-        </p:blipFill>
-        <p:spPr>
-          <a:xfrm>
-            <a:off x="274320" y="1947238"/>
-            <a:ext cx="11612880" cy="3237844"/>
-          </a:xfrm>
-          <a:prstGeom prst="rect">
-            <a:avLst/>
-          </a:prstGeom>
-        </p:spPr>
-      </p:pic>
+              <a:t>Four geometry-based methods implemented</a:t>
+            </a:r>
+          </a:p>
+        </p:txBody>
+      </p:sp>
+      <p:sp>
+        <p:nvSpPr>
+          <p:cNvPr id="4" name="TextBox 3"/>
+          <p:cNvSpPr txBox="1"/>
+          <p:nvPr/>
+        </p:nvSpPr>
+        <p:spPr>
+          <a:xfrm>
+            <a:off x="457200" y="1645920"/>
+            <a:ext cx="11338560" cy="4023360"/>
+          </a:xfrm>
+          <a:prstGeom prst="rect">
+            <a:avLst/>
+          </a:prstGeom>
+          <a:noFill/>
+        </p:spPr>
+        <p:txBody>
+          <a:bodyPr wrap="square">
+            <a:spAutoFit/>
+          </a:bodyPr>
+          <a:lstStyle/>
+          <a:p>
+            <a:pPr algn="l">
+              <a:spcAft>
+                <a:spcPts val="2200"/>
+              </a:spcAft>
+            </a:pPr>
+            <a:r>
+              <a:rPr sz="2100" b="0" i="0">
+                <a:solidFill>
+                  <a:srgbClr val="1F2D3D"/>
+                </a:solidFill>
+                <a:latin typeface="Calibri"/>
+              </a:rPr>
+              <a:t>• 3DTK Hough (baseline) — every point votes for the cylinders it could lie on; the strongest vote wins.</a:t>
+            </a:r>
+          </a:p>
+          <a:p>
+            <a:pPr algn="l">
+              <a:spcAft>
+                <a:spcPts val="2200"/>
+              </a:spcAft>
+            </a:pPr>
+            <a:r>
+              <a:rPr sz="2100" b="0" i="0">
+                <a:solidFill>
+                  <a:srgbClr val="1F2D3D"/>
+                </a:solidFill>
+                <a:latin typeface="Calibri"/>
+              </a:rPr>
+              <a:t>• RANSAC fit — try many random small point samples, keep the cylinder most points agree with.</a:t>
+            </a:r>
+          </a:p>
+          <a:p>
+            <a:pPr algn="l">
+              <a:spcAft>
+                <a:spcPts val="2200"/>
+              </a:spcAft>
+            </a:pPr>
+            <a:r>
+              <a:rPr sz="2100" b="0" i="0">
+                <a:solidFill>
+                  <a:srgbClr val="1F2D3D"/>
+                </a:solidFill>
+                <a:latin typeface="Calibri"/>
+              </a:rPr>
+              <a:t>• Least-squares fit — start from a rough guess, then adjust the cylinder until it matches the points best.</a:t>
+            </a:r>
+          </a:p>
+          <a:p>
+            <a:pPr algn="l">
+              <a:spcAft>
+                <a:spcPts val="2200"/>
+              </a:spcAft>
+            </a:pPr>
+            <a:r>
+              <a:rPr sz="2100" b="0" i="0">
+                <a:solidFill>
+                  <a:srgbClr val="1F2D3D"/>
+                </a:solidFill>
+                <a:latin typeface="Calibri"/>
+              </a:rPr>
+              <a:t>• Efficient RANSAC — a faster RANSAC variant that searches the whole scene for shapes in one pass.</a:t>
+            </a:r>
+          </a:p>
+        </p:txBody>
+      </p:sp>
       <p:sp>
         <p:nvSpPr>
           <p:cNvPr id="5" name="Rectangle 4"/>
@@ -9002,7 +8962,7 @@
         </p:nvSpPr>
         <p:spPr>
           <a:xfrm>
-            <a:off x="365760" y="5852160"/>
+            <a:off x="365760" y="5943600"/>
             <a:ext cx="11475720" cy="502920"/>
           </a:xfrm>
           <a:prstGeom prst="rect">
@@ -9048,7 +9008,7 @@
                 </a:solidFill>
                 <a:latin typeface="Calibri"/>
               </a:rPr>
-              <a:t>A prediction counts as correct if direction is within 30° and the centre within 10 cm of the true drum.</a:t>
+              <a:t>All four: LiDAR points only · no training data · identical input and output — directly comparable.</a:t>
             </a:r>
           </a:p>
         </p:txBody>
@@ -9227,30 +9187,14 @@
                 </a:solidFill>
                 <a:latin typeface="Calibri"/>
               </a:rPr>
-              <a:t>Experiment 1 — computer-generated test clouds</a:t>
-            </a:r>
-          </a:p>
-          <a:p>
-            <a:pPr algn="l">
-              <a:spcAft>
-                <a:spcPts val="800"/>
-              </a:spcAft>
-            </a:pPr>
-            <a:r>
-              <a:rPr sz="1700" b="0" i="0">
-                <a:solidFill>
-                  <a:srgbClr val="D6E6F0"/>
-                </a:solidFill>
-                <a:latin typeface="Calibri"/>
-              </a:rPr>
-              <a:t>Controlled conditions: we know the true cylinder exactly</a:t>
+              <a:t>How we evaluate — one pipeline for every method</a:t>
             </a:r>
           </a:p>
         </p:txBody>
       </p:sp>
       <p:pic>
         <p:nvPicPr>
-          <p:cNvPr id="4" name="Picture 3" descr="synth_data_example.png"/>
+          <p:cNvPr id="4" name="Picture 3" descr="pipeline_flow.png"/>
           <p:cNvPicPr>
             <a:picLocks noChangeAspect="1"/>
           </p:cNvPicPr>
@@ -9264,8 +9208,8 @@
         </p:blipFill>
         <p:spPr>
           <a:xfrm>
-            <a:off x="1800940" y="1371600"/>
-            <a:ext cx="8605359" cy="3108960"/>
+            <a:off x="274320" y="2324279"/>
+            <a:ext cx="11612880" cy="2483761"/>
           </a:xfrm>
           <a:prstGeom prst="rect">
             <a:avLst/>
@@ -9274,68 +9218,13 @@
       </p:pic>
       <p:sp>
         <p:nvSpPr>
-          <p:cNvPr id="5" name="TextBox 4"/>
-          <p:cNvSpPr txBox="1"/>
-          <p:nvPr/>
-        </p:nvSpPr>
-        <p:spPr>
-          <a:xfrm>
-            <a:off x="548640" y="4572000"/>
-            <a:ext cx="11155680" cy="1371600"/>
-          </a:xfrm>
-          <a:prstGeom prst="rect">
-            <a:avLst/>
-          </a:prstGeom>
-          <a:noFill/>
-        </p:spPr>
-        <p:txBody>
-          <a:bodyPr wrap="square">
-            <a:spAutoFit/>
-          </a:bodyPr>
-          <a:lstStyle/>
-          <a:p>
-            <a:pPr algn="l">
-              <a:spcAft>
-                <a:spcPts val="1000"/>
-              </a:spcAft>
-            </a:pPr>
-            <a:r>
-              <a:rPr sz="1900" b="0" i="0">
-                <a:solidFill>
-                  <a:srgbClr val="1F2D3D"/>
-                </a:solidFill>
-                <a:latin typeface="Calibri"/>
-              </a:rPr>
-              <a:t>• 33 clouds of one barrel: only a 120° strip is visible (like a real half-hidden drum).</a:t>
-            </a:r>
-          </a:p>
-          <a:p>
-            <a:pPr algn="l">
-              <a:spcAft>
-                <a:spcPts val="1000"/>
-              </a:spcAft>
-            </a:pPr>
-            <a:r>
-              <a:rPr sz="1900" b="0" i="0">
-                <a:solidFill>
-                  <a:srgbClr val="1F2D3D"/>
-                </a:solidFill>
-                <a:latin typeface="Calibri"/>
-              </a:rPr>
-              <a:t>• Only the measurement noise changes: 11 levels × 3 random repeats.</a:t>
-            </a:r>
-          </a:p>
-        </p:txBody>
-      </p:sp>
-      <p:sp>
-        <p:nvSpPr>
-          <p:cNvPr id="6" name="Rectangle 5"/>
+          <p:cNvPr id="5" name="Rectangle 4"/>
           <p:cNvSpPr/>
           <p:nvPr/>
         </p:nvSpPr>
         <p:spPr>
           <a:xfrm>
-            <a:off x="365760" y="5943600"/>
+            <a:off x="365760" y="5852160"/>
             <a:ext cx="11475720" cy="502920"/>
           </a:xfrm>
           <a:prstGeom prst="rect">
@@ -9381,14 +9270,14 @@
                 </a:solidFill>
                 <a:latin typeface="Calibri"/>
               </a:rPr>
-              <a:t>Question: how much sensor noise can each method tolerate before it fails?</a:t>
-            </a:r>
-          </a:p>
-        </p:txBody>
-      </p:sp>
-      <p:sp>
-        <p:nvSpPr>
-          <p:cNvPr id="7" name="TextBox 6"/>
+              <a:t>A prediction counts as correct if direction is within 30° and the centre within 10 cm of the true drum.</a:t>
+            </a:r>
+          </a:p>
+        </p:txBody>
+      </p:sp>
+      <p:sp>
+        <p:nvSpPr>
+          <p:cNvPr id="6" name="TextBox 5"/>
           <p:cNvSpPr txBox="1"/>
           <p:nvPr/>
         </p:nvSpPr>
@@ -9427,7 +9316,7 @@
       </p:sp>
       <p:sp>
         <p:nvSpPr>
-          <p:cNvPr id="8" name="TextBox 7"/>
+          <p:cNvPr id="7" name="TextBox 6"/>
           <p:cNvSpPr txBox="1"/>
           <p:nvPr/>
         </p:nvSpPr>
@@ -9560,7 +9449,7 @@
                 </a:solidFill>
                 <a:latin typeface="Calibri"/>
               </a:rPr>
-              <a:t>Experiment 1 — results</a:t>
+              <a:t>Experiment 1 — how much noise can each method take?</a:t>
             </a:r>
           </a:p>
           <a:p>
@@ -9576,7 +9465,7 @@
                 </a:solidFill>
                 <a:latin typeface="Calibri"/>
               </a:rPr>
-              <a:t>Lower error is better; F1 = 1 means the barrel was always found, with no false alarms</a:t>
+              <a:t>The synthetic barrel (120° visible) at 11 noise levels × 3 repeats = 33 test clouds</a:t>
             </a:r>
           </a:p>
         </p:txBody>

</xml_diff>

<commit_message>
Eval deck v3.1: trim risks table and move it before roadmap, add thank-you slide, capitalize chart text
</commit_message>
<xml_diff>
--- a/researchwrite/evaluation_presentation.pptx
+++ b/researchwrite/evaluation_presentation.pptx
@@ -23,6 +23,7 @@
     <p:sldId id="271" r:id="rId22"/>
     <p:sldId id="272" r:id="rId23"/>
     <p:sldId id="273" r:id="rId24"/>
+    <p:sldId id="274" r:id="rId25"/>
   </p:sldIdLst>
   <p:sldSz cx="12191695" cy="6858000" type="screen4x3"/>
   <p:notesSz cx="6858000" cy="9144000"/>
@@ -3478,7 +3479,7 @@
                 </a:solidFill>
                 <a:latin typeface="Calibri"/>
               </a:rPr>
-              <a:t>camera points (coloured) with the fitted cylinder (red)</a:t>
+              <a:t>Camera points (coloured) with the fitted cylinder (red)</a:t>
             </a:r>
           </a:p>
         </p:txBody>
@@ -4289,7 +4290,7 @@
                 </a:solidFill>
                 <a:latin typeface="Calibri"/>
               </a:rPr>
-              <a:t>true drum (green) vs fitted cylinders on the real points</a:t>
+              <a:t>True drum (green) vs fitted cylinders on the real points</a:t>
             </a:r>
           </a:p>
         </p:txBody>
@@ -4677,7 +4678,7 @@
                 </a:solidFill>
                 <a:latin typeface="Calibri"/>
               </a:rPr>
-              <a:t>examples of the synthetic training patches: simulated LiDAR points (red) on the drum surface (blue)</a:t>
+              <a:t>Examples of the synthetic training patches: simulated LiDAR points (red) on the drum surface (blue)</a:t>
             </a:r>
           </a:p>
         </p:txBody>
@@ -5307,7 +5308,7 @@
                 </a:solidFill>
                 <a:latin typeface="Calibri"/>
               </a:rPr>
-              <a:t>annotated drums coloured; predicted cylinders: green = within gate, red = miss</a:t>
+              <a:t>Annotated drums coloured; predicted cylinders: green = within gate, red = miss</a:t>
             </a:r>
           </a:p>
         </p:txBody>
@@ -5898,296 +5899,6 @@
                 </a:solidFill>
                 <a:latin typeface="Calibri"/>
               </a:rPr>
-              <a:t>Next step: simulation closes the data gap</a:t>
-            </a:r>
-          </a:p>
-          <a:p>
-            <a:pPr algn="l">
-              <a:spcAft>
-                <a:spcPts val="800"/>
-              </a:spcAft>
-            </a:pPr>
-            <a:r>
-              <a:rPr sz="1700" b="0" i="0">
-                <a:solidFill>
-                  <a:srgbClr val="D6E6F0"/>
-                </a:solidFill>
-                <a:latin typeface="Calibri"/>
-              </a:rPr>
-              <a:t>NVIDIA Isaac Sim gives unlimited scenes with perfect ground truth</a:t>
-            </a:r>
-          </a:p>
-        </p:txBody>
-      </p:sp>
-      <p:pic>
-        <p:nvPicPr>
-          <p:cNvPr id="4" name="Picture 3" descr="roadmap.png"/>
-          <p:cNvPicPr>
-            <a:picLocks noChangeAspect="1"/>
-          </p:cNvPicPr>
-          <p:nvPr/>
-        </p:nvPicPr>
-        <p:blipFill>
-          <a:blip r:embed="rId2"/>
-          <a:stretch>
-            <a:fillRect/>
-          </a:stretch>
-        </p:blipFill>
-        <p:spPr>
-          <a:xfrm>
-            <a:off x="2412515" y="1463040"/>
-            <a:ext cx="7336489" cy="2377440"/>
-          </a:xfrm>
-          <a:prstGeom prst="rect">
-            <a:avLst/>
-          </a:prstGeom>
-        </p:spPr>
-      </p:pic>
-      <p:sp>
-        <p:nvSpPr>
-          <p:cNvPr id="5" name="TextBox 4"/>
-          <p:cNvSpPr txBox="1"/>
-          <p:nvPr/>
-        </p:nvSpPr>
-        <p:spPr>
-          <a:xfrm>
-            <a:off x="548640" y="3977639"/>
-            <a:ext cx="11155680" cy="1828800"/>
-          </a:xfrm>
-          <a:prstGeom prst="rect">
-            <a:avLst/>
-          </a:prstGeom>
-          <a:noFill/>
-        </p:spPr>
-        <p:txBody>
-          <a:bodyPr wrap="square">
-            <a:spAutoFit/>
-          </a:bodyPr>
-          <a:lstStyle/>
-          <a:p>
-            <a:pPr algn="l">
-              <a:spcAft>
-                <a:spcPts val="1000"/>
-              </a:spcAft>
-            </a:pPr>
-            <a:r>
-              <a:rPr sz="2000" b="0" i="0">
-                <a:solidFill>
-                  <a:srgbClr val="1F2D3D"/>
-                </a:solidFill>
-                <a:latin typeface="Calibri"/>
-              </a:rPr>
-              <a:t>• Every simulated drum comes with its exact pose and its exact degree of burial — labels for free.</a:t>
-            </a:r>
-          </a:p>
-          <a:p>
-            <a:pPr algn="l">
-              <a:spcAft>
-                <a:spcPts val="1000"/>
-              </a:spcAft>
-            </a:pPr>
-            <a:r>
-              <a:rPr sz="2000" b="0" i="0">
-                <a:solidFill>
-                  <a:srgbClr val="1F2D3D"/>
-                </a:solidFill>
-                <a:latin typeface="Calibri"/>
-              </a:rPr>
-              <a:t>• That enables the headline experiment: detection quality as a function of how much of the drum is hidden.</a:t>
-            </a:r>
-          </a:p>
-          <a:p>
-            <a:pPr algn="l">
-              <a:spcAft>
-                <a:spcPts val="1000"/>
-              </a:spcAft>
-            </a:pPr>
-            <a:r>
-              <a:rPr sz="2000" b="0" i="0">
-                <a:solidFill>
-                  <a:srgbClr val="1F2D3D"/>
-                </a:solidFill>
-                <a:latin typeface="Calibri"/>
-              </a:rPr>
-              <a:t>• And it unlocks the remaining families: more learned methods and camera + LiDAR fusion.</a:t>
-            </a:r>
-          </a:p>
-        </p:txBody>
-      </p:sp>
-      <p:sp>
-        <p:nvSpPr>
-          <p:cNvPr id="6" name="TextBox 5"/>
-          <p:cNvSpPr txBox="1"/>
-          <p:nvPr/>
-        </p:nvSpPr>
-        <p:spPr>
-          <a:xfrm>
-            <a:off x="365760" y="6473952"/>
-            <a:ext cx="10972800" cy="320040"/>
-          </a:xfrm>
-          <a:prstGeom prst="rect">
-            <a:avLst/>
-          </a:prstGeom>
-          <a:noFill/>
-        </p:spPr>
-        <p:txBody>
-          <a:bodyPr wrap="square">
-            <a:spAutoFit/>
-          </a:bodyPr>
-          <a:lstStyle/>
-          <a:p>
-            <a:pPr algn="l">
-              <a:spcAft>
-                <a:spcPts val="800"/>
-              </a:spcAft>
-            </a:pPr>
-            <a:r>
-              <a:rPr sz="1000" b="0" i="0">
-                <a:solidFill>
-                  <a:srgbClr val="555555"/>
-                </a:solidFill>
-                <a:latin typeface="Calibri"/>
-              </a:rPr>
-              <a:t>Detection and Robotic Manipulation of Partially Occluded Object(s)</a:t>
-            </a:r>
-          </a:p>
-        </p:txBody>
-      </p:sp>
-      <p:sp>
-        <p:nvSpPr>
-          <p:cNvPr id="7" name="TextBox 6"/>
-          <p:cNvSpPr txBox="1"/>
-          <p:nvPr/>
-        </p:nvSpPr>
-        <p:spPr>
-          <a:xfrm>
-            <a:off x="11521440" y="6473952"/>
-            <a:ext cx="548640" cy="320040"/>
-          </a:xfrm>
-          <a:prstGeom prst="rect">
-            <a:avLst/>
-          </a:prstGeom>
-          <a:noFill/>
-        </p:spPr>
-        <p:txBody>
-          <a:bodyPr wrap="square">
-            <a:spAutoFit/>
-          </a:bodyPr>
-          <a:lstStyle/>
-          <a:p>
-            <a:pPr algn="r">
-              <a:spcAft>
-                <a:spcPts val="800"/>
-              </a:spcAft>
-            </a:pPr>
-            <a:r>
-              <a:rPr sz="1100" b="0" i="0">
-                <a:solidFill>
-                  <a:srgbClr val="555555"/>
-                </a:solidFill>
-                <a:latin typeface="Calibri"/>
-              </a:rPr>
-              <a:t>15</a:t>
-            </a:r>
-          </a:p>
-        </p:txBody>
-      </p:sp>
-    </p:spTree>
-  </p:cSld>
-  <p:clrMapOvr>
-    <a:masterClrMapping/>
-  </p:clrMapOvr>
-</p:sld>
-</file>
-
-<file path=ppt/slides/slide17.xml><?xml version="1.0" encoding="utf-8"?>
-<p:sld xmlns:a="http://schemas.openxmlformats.org/drawingml/2006/main" xmlns:p="http://schemas.openxmlformats.org/presentationml/2006/main" xmlns:r="http://schemas.openxmlformats.org/officeDocument/2006/relationships">
-  <p:cSld>
-    <p:spTree>
-      <p:nvGrpSpPr>
-        <p:cNvPr id="1" name=""/>
-        <p:cNvGrpSpPr/>
-        <p:nvPr/>
-      </p:nvGrpSpPr>
-      <p:grpSpPr/>
-      <p:sp>
-        <p:nvSpPr>
-          <p:cNvPr id="2" name="Rectangle 1"/>
-          <p:cNvSpPr/>
-          <p:nvPr/>
-        </p:nvSpPr>
-        <p:spPr>
-          <a:xfrm>
-            <a:off x="0" y="0"/>
-            <a:ext cx="12191695" cy="1051560"/>
-          </a:xfrm>
-          <a:prstGeom prst="rect">
-            <a:avLst/>
-          </a:prstGeom>
-          <a:solidFill>
-            <a:srgbClr val="0B5C8A"/>
-          </a:solidFill>
-          <a:ln>
-            <a:noFill/>
-          </a:ln>
-          <a:effectLst/>
-        </p:spPr>
-        <p:style>
-          <a:lnRef idx="1">
-            <a:schemeClr val="accent1"/>
-          </a:lnRef>
-          <a:fillRef idx="3">
-            <a:schemeClr val="accent1"/>
-          </a:fillRef>
-          <a:effectRef idx="2">
-            <a:schemeClr val="accent1"/>
-          </a:effectRef>
-          <a:fontRef idx="minor">
-            <a:schemeClr val="lt1"/>
-          </a:fontRef>
-        </p:style>
-        <p:txBody>
-          <a:bodyPr rtlCol="0" anchor="ctr"/>
-          <a:lstStyle/>
-          <a:p>
-            <a:pPr algn="ctr"/>
-          </a:p>
-        </p:txBody>
-      </p:sp>
-      <p:sp>
-        <p:nvSpPr>
-          <p:cNvPr id="3" name="TextBox 2"/>
-          <p:cNvSpPr txBox="1"/>
-          <p:nvPr/>
-        </p:nvSpPr>
-        <p:spPr>
-          <a:xfrm>
-            <a:off x="457200" y="91440"/>
-            <a:ext cx="11247120" cy="914400"/>
-          </a:xfrm>
-          <a:prstGeom prst="rect">
-            <a:avLst/>
-          </a:prstGeom>
-          <a:noFill/>
-        </p:spPr>
-        <p:txBody>
-          <a:bodyPr wrap="square">
-            <a:spAutoFit/>
-          </a:bodyPr>
-          <a:lstStyle/>
-          <a:p>
-            <a:pPr algn="l">
-              <a:spcAft>
-                <a:spcPts val="800"/>
-              </a:spcAft>
-            </a:pPr>
-            <a:r>
-              <a:rPr sz="3000" b="1" i="0">
-                <a:solidFill>
-                  <a:srgbClr val="FFFFFF"/>
-                </a:solidFill>
-                <a:latin typeface="Calibri"/>
-              </a:rPr>
               <a:t>Open risks — and how we deal with them</a:t>
             </a:r>
           </a:p>
@@ -6202,8 +5913,8 @@
           <p:nvPr/>
         </p:nvGraphicFramePr>
         <p:xfrm>
-          <a:off x="411480" y="1371600"/>
-          <a:ext cx="11384280" cy="4297680"/>
+          <a:off x="411480" y="1463040"/>
+          <a:ext cx="11384280" cy="3840480"/>
         </p:xfrm>
         <a:graphic>
           <a:graphicData uri="http://schemas.openxmlformats.org/drawingml/2006/table">
@@ -6212,10 +5923,10 @@
                 <a:tableStyleId>{5C22544A-7EE6-4342-B048-85BDC9FD1C3A}</a:tableStyleId>
               </a:tblPr>
               <a:tblGrid>
-                <a:gridCol w="5212080"/>
-                <a:gridCol w="6172200"/>
+                <a:gridCol w="4754880"/>
+                <a:gridCol w="6629400"/>
               </a:tblGrid>
-              <a:tr h="859536">
+              <a:tr h="768096">
                 <a:tc>
                   <a:txBody>
                     <a:bodyPr/>
@@ -6223,7 +5934,7 @@
                     <a:p>
                       <a:pPr algn="l"/>
                       <a:r>
-                        <a:rPr sz="1700" b="1">
+                        <a:rPr sz="1900" b="1">
                           <a:solidFill>
                             <a:srgbClr val="FFFFFF"/>
                           </a:solidFill>
@@ -6246,7 +5957,7 @@
                     <a:p>
                       <a:pPr algn="ctr"/>
                       <a:r>
-                        <a:rPr sz="1700" b="1">
+                        <a:rPr sz="1900" b="1">
                           <a:solidFill>
                             <a:srgbClr val="FFFFFF"/>
                           </a:solidFill>
@@ -6263,7 +5974,7 @@
                   </a:tcPr>
                 </a:tc>
               </a:tr>
-              <a:tr h="859536">
+              <a:tr h="768096">
                 <a:tc>
                   <a:txBody>
                     <a:bodyPr/>
@@ -6271,13 +5982,13 @@
                     <a:p>
                       <a:pPr algn="l"/>
                       <a:r>
-                        <a:rPr sz="1600" b="0">
+                        <a:rPr sz="1800" b="0">
                           <a:solidFill>
                             <a:srgbClr val="1F2D3D"/>
                           </a:solidFill>
                           <a:latin typeface="Calibri"/>
                         </a:rPr>
-                        <a:t>Detection accuracy collapses under occlusion (seen across the field, e.g. −47% for LiDAR-only in a 2025 study)</a:t>
+                        <a:t>Accuracy collapses under occlusion</a:t>
                       </a:r>
                     </a:p>
                   </a:txBody>
@@ -6294,13 +6005,13 @@
                     <a:p>
                       <a:pPr algn="ctr"/>
                       <a:r>
-                        <a:rPr sz="1600" b="0">
+                        <a:rPr sz="1800" b="0">
                           <a:solidFill>
                             <a:srgbClr val="1F2D3D"/>
                           </a:solidFill>
                           <a:latin typeface="Calibri"/>
                         </a:rPr>
-                        <a:t>Measure it systematically per method (occlusion sweep) instead of assuming — that comparison IS the thesis.</a:t>
+                        <a:t>Measure it per method — that comparison IS the thesis.</a:t>
                       </a:r>
                     </a:p>
                   </a:txBody>
@@ -6311,7 +6022,7 @@
                   </a:tcPr>
                 </a:tc>
               </a:tr>
-              <a:tr h="859536">
+              <a:tr h="768096">
                 <a:tc>
                   <a:txBody>
                     <a:bodyPr/>
@@ -6319,13 +6030,13 @@
                     <a:p>
                       <a:pPr algn="l"/>
                       <a:r>
-                        <a:rPr sz="1600" b="0">
+                        <a:rPr sz="1800" b="0">
                           <a:solidFill>
                             <a:srgbClr val="1F2D3D"/>
                           </a:solidFill>
                           <a:latin typeface="Calibri"/>
                         </a:rPr>
-                        <a:t>One sensor alone may never be reliable enough</a:t>
+                        <a:t>One sensor alone may not be enough</a:t>
                       </a:r>
                     </a:p>
                   </a:txBody>
@@ -6342,13 +6053,13 @@
                     <a:p>
                       <a:pPr algn="ctr"/>
                       <a:r>
-                        <a:rPr sz="1600" b="0">
+                        <a:rPr sz="1800" b="0">
                           <a:solidFill>
                             <a:srgbClr val="1F2D3D"/>
                           </a:solidFill>
                           <a:latin typeface="Calibri"/>
                         </a:rPr>
-                        <a:t>Camera + LiDAR fusion is planned; literature shows fusion degrades far more gracefully.</a:t>
+                        <a:t>Add camera + LiDAR fusion — it degrades far more gracefully.</a:t>
                       </a:r>
                     </a:p>
                   </a:txBody>
@@ -6359,7 +6070,7 @@
                   </a:tcPr>
                 </a:tc>
               </a:tr>
-              <a:tr h="859536">
+              <a:tr h="768096">
                 <a:tc>
                   <a:txBody>
                     <a:bodyPr/>
@@ -6367,13 +6078,13 @@
                     <a:p>
                       <a:pPr algn="l"/>
                       <a:r>
-                        <a:rPr sz="1600" b="0">
+                        <a:rPr sz="1800" b="0">
                           <a:solidFill>
                             <a:srgbClr val="1F2D3D"/>
                           </a:solidFill>
                           <a:latin typeface="Calibri"/>
                         </a:rPr>
-                        <a:t>Models trained in simulation may not transfer to reality</a:t>
+                        <a:t>Sim-trained models may not transfer</a:t>
                       </a:r>
                     </a:p>
                   </a:txBody>
@@ -6390,13 +6101,13 @@
                     <a:p>
                       <a:pPr algn="ctr"/>
                       <a:r>
-                        <a:rPr sz="1600" b="0">
+                        <a:rPr sz="1800" b="0">
                           <a:solidFill>
                             <a:srgbClr val="1F2D3D"/>
                           </a:solidFill>
                           <a:latin typeface="Calibri"/>
                         </a:rPr>
-                        <a:t>BarrelNet already measures this transfer on 21 real drums (12/21); next: fine-tune on a handful of real drums.</a:t>
+                        <a:t>Measured: 12 of 21 real drums; next, fine-tune on a few real ones.</a:t>
                       </a:r>
                     </a:p>
                   </a:txBody>
@@ -6407,7 +6118,7 @@
                   </a:tcPr>
                 </a:tc>
               </a:tr>
-              <a:tr h="859536">
+              <a:tr h="768096">
                 <a:tc>
                   <a:txBody>
                     <a:bodyPr/>
@@ -6415,13 +6126,13 @@
                     <a:p>
                       <a:pPr algn="l"/>
                       <a:r>
-                        <a:rPr sz="1600" b="0">
+                        <a:rPr sz="1800" b="0">
                           <a:solidFill>
                             <a:srgbClr val="1F2D3D"/>
                           </a:solidFill>
                           <a:latin typeface="Calibri"/>
                         </a:rPr>
-                        <a:t>The manipulation half of the title is not started yet</a:t>
+                        <a:t>Manipulation not started yet</a:t>
                       </a:r>
                     </a:p>
                   </a:txBody>
@@ -6438,13 +6149,13 @@
                     <a:p>
                       <a:pPr algn="ctr"/>
                       <a:r>
-                        <a:rPr sz="1600" b="0">
+                        <a:rPr sz="1800" b="0">
                           <a:solidFill>
                             <a:srgbClr val="1F2D3D"/>
                           </a:solidFill>
                           <a:latin typeface="Calibri"/>
                         </a:rPr>
-                        <a:t>Detection outputs exactly the pose a grasp planner needs; manipulation follows the method comparison.</a:t>
+                        <a:t>Detection delivers exactly the pose a grasp planner needs.</a:t>
                       </a:r>
                     </a:p>
                   </a:txBody>
@@ -6493,7 +6204,297 @@
                 </a:solidFill>
                 <a:latin typeface="Calibri"/>
               </a:rPr>
-              <a:t>occlusion numbers: [Shi'19] arXiv:1812.04244 · [Kumar'25] arXiv:2511.04347 · [Wang'25] Sensors 25(9):2794</a:t>
+              <a:t>Occlusion numbers: [Shi'19] arXiv:1812.04244 · [Kumar'25] arXiv:2511.04347 · [Wang'25] Sensors 25(9):2794</a:t>
+            </a:r>
+          </a:p>
+        </p:txBody>
+      </p:sp>
+      <p:sp>
+        <p:nvSpPr>
+          <p:cNvPr id="6" name="TextBox 5"/>
+          <p:cNvSpPr txBox="1"/>
+          <p:nvPr/>
+        </p:nvSpPr>
+        <p:spPr>
+          <a:xfrm>
+            <a:off x="365760" y="6473952"/>
+            <a:ext cx="10972800" cy="320040"/>
+          </a:xfrm>
+          <a:prstGeom prst="rect">
+            <a:avLst/>
+          </a:prstGeom>
+          <a:noFill/>
+        </p:spPr>
+        <p:txBody>
+          <a:bodyPr wrap="square">
+            <a:spAutoFit/>
+          </a:bodyPr>
+          <a:lstStyle/>
+          <a:p>
+            <a:pPr algn="l">
+              <a:spcAft>
+                <a:spcPts val="800"/>
+              </a:spcAft>
+            </a:pPr>
+            <a:r>
+              <a:rPr sz="1000" b="0" i="0">
+                <a:solidFill>
+                  <a:srgbClr val="555555"/>
+                </a:solidFill>
+                <a:latin typeface="Calibri"/>
+              </a:rPr>
+              <a:t>Detection and Robotic Manipulation of Partially Occluded Object(s)</a:t>
+            </a:r>
+          </a:p>
+        </p:txBody>
+      </p:sp>
+      <p:sp>
+        <p:nvSpPr>
+          <p:cNvPr id="7" name="TextBox 6"/>
+          <p:cNvSpPr txBox="1"/>
+          <p:nvPr/>
+        </p:nvSpPr>
+        <p:spPr>
+          <a:xfrm>
+            <a:off x="11521440" y="6473952"/>
+            <a:ext cx="548640" cy="320040"/>
+          </a:xfrm>
+          <a:prstGeom prst="rect">
+            <a:avLst/>
+          </a:prstGeom>
+          <a:noFill/>
+        </p:spPr>
+        <p:txBody>
+          <a:bodyPr wrap="square">
+            <a:spAutoFit/>
+          </a:bodyPr>
+          <a:lstStyle/>
+          <a:p>
+            <a:pPr algn="r">
+              <a:spcAft>
+                <a:spcPts val="800"/>
+              </a:spcAft>
+            </a:pPr>
+            <a:r>
+              <a:rPr sz="1100" b="0" i="0">
+                <a:solidFill>
+                  <a:srgbClr val="555555"/>
+                </a:solidFill>
+                <a:latin typeface="Calibri"/>
+              </a:rPr>
+              <a:t>15</a:t>
+            </a:r>
+          </a:p>
+        </p:txBody>
+      </p:sp>
+    </p:spTree>
+  </p:cSld>
+  <p:clrMapOvr>
+    <a:masterClrMapping/>
+  </p:clrMapOvr>
+</p:sld>
+</file>
+
+<file path=ppt/slides/slide17.xml><?xml version="1.0" encoding="utf-8"?>
+<p:sld xmlns:a="http://schemas.openxmlformats.org/drawingml/2006/main" xmlns:p="http://schemas.openxmlformats.org/presentationml/2006/main" xmlns:r="http://schemas.openxmlformats.org/officeDocument/2006/relationships">
+  <p:cSld>
+    <p:spTree>
+      <p:nvGrpSpPr>
+        <p:cNvPr id="1" name=""/>
+        <p:cNvGrpSpPr/>
+        <p:nvPr/>
+      </p:nvGrpSpPr>
+      <p:grpSpPr/>
+      <p:sp>
+        <p:nvSpPr>
+          <p:cNvPr id="2" name="Rectangle 1"/>
+          <p:cNvSpPr/>
+          <p:nvPr/>
+        </p:nvSpPr>
+        <p:spPr>
+          <a:xfrm>
+            <a:off x="0" y="0"/>
+            <a:ext cx="12191695" cy="1051560"/>
+          </a:xfrm>
+          <a:prstGeom prst="rect">
+            <a:avLst/>
+          </a:prstGeom>
+          <a:solidFill>
+            <a:srgbClr val="0B5C8A"/>
+          </a:solidFill>
+          <a:ln>
+            <a:noFill/>
+          </a:ln>
+          <a:effectLst/>
+        </p:spPr>
+        <p:style>
+          <a:lnRef idx="1">
+            <a:schemeClr val="accent1"/>
+          </a:lnRef>
+          <a:fillRef idx="3">
+            <a:schemeClr val="accent1"/>
+          </a:fillRef>
+          <a:effectRef idx="2">
+            <a:schemeClr val="accent1"/>
+          </a:effectRef>
+          <a:fontRef idx="minor">
+            <a:schemeClr val="lt1"/>
+          </a:fontRef>
+        </p:style>
+        <p:txBody>
+          <a:bodyPr rtlCol="0" anchor="ctr"/>
+          <a:lstStyle/>
+          <a:p>
+            <a:pPr algn="ctr"/>
+          </a:p>
+        </p:txBody>
+      </p:sp>
+      <p:sp>
+        <p:nvSpPr>
+          <p:cNvPr id="3" name="TextBox 2"/>
+          <p:cNvSpPr txBox="1"/>
+          <p:nvPr/>
+        </p:nvSpPr>
+        <p:spPr>
+          <a:xfrm>
+            <a:off x="457200" y="91440"/>
+            <a:ext cx="11247120" cy="914400"/>
+          </a:xfrm>
+          <a:prstGeom prst="rect">
+            <a:avLst/>
+          </a:prstGeom>
+          <a:noFill/>
+        </p:spPr>
+        <p:txBody>
+          <a:bodyPr wrap="square">
+            <a:spAutoFit/>
+          </a:bodyPr>
+          <a:lstStyle/>
+          <a:p>
+            <a:pPr algn="l">
+              <a:spcAft>
+                <a:spcPts val="800"/>
+              </a:spcAft>
+            </a:pPr>
+            <a:r>
+              <a:rPr sz="3000" b="1" i="0">
+                <a:solidFill>
+                  <a:srgbClr val="FFFFFF"/>
+                </a:solidFill>
+                <a:latin typeface="Calibri"/>
+              </a:rPr>
+              <a:t>Next step: simulation closes the data gap</a:t>
+            </a:r>
+          </a:p>
+          <a:p>
+            <a:pPr algn="l">
+              <a:spcAft>
+                <a:spcPts val="800"/>
+              </a:spcAft>
+            </a:pPr>
+            <a:r>
+              <a:rPr sz="1700" b="0" i="0">
+                <a:solidFill>
+                  <a:srgbClr val="D6E6F0"/>
+                </a:solidFill>
+                <a:latin typeface="Calibri"/>
+              </a:rPr>
+              <a:t>NVIDIA Isaac Sim gives unlimited scenes with perfect ground truth</a:t>
+            </a:r>
+          </a:p>
+        </p:txBody>
+      </p:sp>
+      <p:pic>
+        <p:nvPicPr>
+          <p:cNvPr id="4" name="Picture 3" descr="roadmap.png"/>
+          <p:cNvPicPr>
+            <a:picLocks noChangeAspect="1"/>
+          </p:cNvPicPr>
+          <p:nvPr/>
+        </p:nvPicPr>
+        <p:blipFill>
+          <a:blip r:embed="rId2"/>
+          <a:stretch>
+            <a:fillRect/>
+          </a:stretch>
+        </p:blipFill>
+        <p:spPr>
+          <a:xfrm>
+            <a:off x="2412515" y="1463040"/>
+            <a:ext cx="7336489" cy="2377440"/>
+          </a:xfrm>
+          <a:prstGeom prst="rect">
+            <a:avLst/>
+          </a:prstGeom>
+        </p:spPr>
+      </p:pic>
+      <p:sp>
+        <p:nvSpPr>
+          <p:cNvPr id="5" name="TextBox 4"/>
+          <p:cNvSpPr txBox="1"/>
+          <p:nvPr/>
+        </p:nvSpPr>
+        <p:spPr>
+          <a:xfrm>
+            <a:off x="548640" y="3977639"/>
+            <a:ext cx="11155680" cy="1828800"/>
+          </a:xfrm>
+          <a:prstGeom prst="rect">
+            <a:avLst/>
+          </a:prstGeom>
+          <a:noFill/>
+        </p:spPr>
+        <p:txBody>
+          <a:bodyPr wrap="square">
+            <a:spAutoFit/>
+          </a:bodyPr>
+          <a:lstStyle/>
+          <a:p>
+            <a:pPr algn="l">
+              <a:spcAft>
+                <a:spcPts val="1000"/>
+              </a:spcAft>
+            </a:pPr>
+            <a:r>
+              <a:rPr sz="2000" b="0" i="0">
+                <a:solidFill>
+                  <a:srgbClr val="1F2D3D"/>
+                </a:solidFill>
+                <a:latin typeface="Calibri"/>
+              </a:rPr>
+              <a:t>• Every simulated drum comes with its exact pose and its exact degree of burial — labels for free.</a:t>
+            </a:r>
+          </a:p>
+          <a:p>
+            <a:pPr algn="l">
+              <a:spcAft>
+                <a:spcPts val="1000"/>
+              </a:spcAft>
+            </a:pPr>
+            <a:r>
+              <a:rPr sz="2000" b="0" i="0">
+                <a:solidFill>
+                  <a:srgbClr val="1F2D3D"/>
+                </a:solidFill>
+                <a:latin typeface="Calibri"/>
+              </a:rPr>
+              <a:t>• That enables the headline experiment: detection quality as a function of how much of the drum is hidden.</a:t>
+            </a:r>
+          </a:p>
+          <a:p>
+            <a:pPr algn="l">
+              <a:spcAft>
+                <a:spcPts val="1000"/>
+              </a:spcAft>
+            </a:pPr>
+            <a:r>
+              <a:rPr sz="2000" b="0" i="0">
+                <a:solidFill>
+                  <a:srgbClr val="1F2D3D"/>
+                </a:solidFill>
+                <a:latin typeface="Calibri"/>
+              </a:rPr>
+              <a:t>• And it unlocks the remaining families: more learned methods and camera + LiDAR fusion.</a:t>
             </a:r>
           </a:p>
         </p:txBody>
@@ -6909,6 +6910,167 @@
 </p:sld>
 </file>
 
+<file path=ppt/slides/slide19.xml><?xml version="1.0" encoding="utf-8"?>
+<p:sld xmlns:a="http://schemas.openxmlformats.org/drawingml/2006/main" xmlns:p="http://schemas.openxmlformats.org/presentationml/2006/main" xmlns:r="http://schemas.openxmlformats.org/officeDocument/2006/relationships">
+  <p:cSld>
+    <p:spTree>
+      <p:nvGrpSpPr>
+        <p:cNvPr id="1" name=""/>
+        <p:cNvGrpSpPr/>
+        <p:nvPr/>
+      </p:nvGrpSpPr>
+      <p:grpSpPr/>
+      <p:sp>
+        <p:nvSpPr>
+          <p:cNvPr id="2" name="Rectangle 1"/>
+          <p:cNvSpPr/>
+          <p:nvPr/>
+        </p:nvSpPr>
+        <p:spPr>
+          <a:xfrm>
+            <a:off x="0" y="0"/>
+            <a:ext cx="12191695" cy="6858000"/>
+          </a:xfrm>
+          <a:prstGeom prst="rect">
+            <a:avLst/>
+          </a:prstGeom>
+          <a:solidFill>
+            <a:srgbClr val="1F2D3D"/>
+          </a:solidFill>
+          <a:ln>
+            <a:noFill/>
+          </a:ln>
+          <a:effectLst/>
+        </p:spPr>
+        <p:style>
+          <a:lnRef idx="1">
+            <a:schemeClr val="accent1"/>
+          </a:lnRef>
+          <a:fillRef idx="3">
+            <a:schemeClr val="accent1"/>
+          </a:fillRef>
+          <a:effectRef idx="2">
+            <a:schemeClr val="accent1"/>
+          </a:effectRef>
+          <a:fontRef idx="minor">
+            <a:schemeClr val="lt1"/>
+          </a:fontRef>
+        </p:style>
+        <p:txBody>
+          <a:bodyPr rtlCol="0" anchor="ctr"/>
+          <a:lstStyle/>
+          <a:p>
+            <a:pPr algn="ctr"/>
+          </a:p>
+        </p:txBody>
+      </p:sp>
+      <p:sp>
+        <p:nvSpPr>
+          <p:cNvPr id="3" name="Rectangle 2"/>
+          <p:cNvSpPr/>
+          <p:nvPr/>
+        </p:nvSpPr>
+        <p:spPr>
+          <a:xfrm>
+            <a:off x="0" y="0"/>
+            <a:ext cx="12191695" cy="164592"/>
+          </a:xfrm>
+          <a:prstGeom prst="rect">
+            <a:avLst/>
+          </a:prstGeom>
+          <a:solidFill>
+            <a:srgbClr val="0B5C8A"/>
+          </a:solidFill>
+          <a:ln>
+            <a:noFill/>
+          </a:ln>
+          <a:effectLst/>
+        </p:spPr>
+        <p:style>
+          <a:lnRef idx="1">
+            <a:schemeClr val="accent1"/>
+          </a:lnRef>
+          <a:fillRef idx="3">
+            <a:schemeClr val="accent1"/>
+          </a:fillRef>
+          <a:effectRef idx="2">
+            <a:schemeClr val="accent1"/>
+          </a:effectRef>
+          <a:fontRef idx="minor">
+            <a:schemeClr val="lt1"/>
+          </a:fontRef>
+        </p:style>
+        <p:txBody>
+          <a:bodyPr rtlCol="0" anchor="ctr"/>
+          <a:lstStyle/>
+          <a:p>
+            <a:pPr algn="ctr"/>
+          </a:p>
+        </p:txBody>
+      </p:sp>
+      <p:sp>
+        <p:nvSpPr>
+          <p:cNvPr id="4" name="TextBox 3"/>
+          <p:cNvSpPr txBox="1"/>
+          <p:nvPr/>
+        </p:nvSpPr>
+        <p:spPr>
+          <a:xfrm>
+            <a:off x="822960" y="2560320"/>
+            <a:ext cx="10607040" cy="1828800"/>
+          </a:xfrm>
+          <a:prstGeom prst="rect">
+            <a:avLst/>
+          </a:prstGeom>
+          <a:noFill/>
+        </p:spPr>
+        <p:txBody>
+          <a:bodyPr wrap="square">
+            <a:spAutoFit/>
+          </a:bodyPr>
+          <a:lstStyle/>
+          <a:p>
+            <a:pPr algn="ctr">
+              <a:spcAft>
+                <a:spcPts val="800"/>
+              </a:spcAft>
+            </a:pPr>
+            <a:r>
+              <a:rPr sz="4800" b="1" i="0">
+                <a:solidFill>
+                  <a:srgbClr val="FFFFFF"/>
+                </a:solidFill>
+                <a:latin typeface="Calibri"/>
+              </a:rPr>
+              <a:t>Thank you!</a:t>
+            </a:r>
+          </a:p>
+          <a:p>
+            <a:pPr algn="ctr">
+              <a:spcAft>
+                <a:spcPts val="800"/>
+              </a:spcAft>
+            </a:pPr>
+            <a:r>
+              <a:rPr sz="2400" b="0" i="0">
+                <a:solidFill>
+                  <a:srgbClr val="9FC5DD"/>
+                </a:solidFill>
+                <a:latin typeface="Calibri"/>
+              </a:rPr>
+              <a:t>Questions?</a:t>
+            </a:r>
+          </a:p>
+        </p:txBody>
+      </p:sp>
+    </p:spTree>
+  </p:cSld>
+  <p:clrMapOvr>
+    <a:masterClrMapping/>
+  </p:clrMapOvr>
+</p:sld>
+</file>
+
 <file path=ppt/slides/slide2.xml><?xml version="1.0" encoding="utf-8"?>
 <p:sld xmlns:a="http://schemas.openxmlformats.org/drawingml/2006/main" xmlns:p="http://schemas.openxmlformats.org/presentationml/2006/main" xmlns:r="http://schemas.openxmlformats.org/officeDocument/2006/relationships">
   <p:cSld>
@@ -8621,8 +8783,8 @@
         </p:blipFill>
         <p:spPr>
           <a:xfrm>
-            <a:off x="274320" y="1504403"/>
-            <a:ext cx="11612880" cy="4123513"/>
+            <a:off x="274320" y="1507659"/>
+            <a:ext cx="11612880" cy="4117002"/>
           </a:xfrm>
           <a:prstGeom prst="rect">
             <a:avLst/>

</xml_diff>